<commit_message>
Refresh project documentation and verification evidence
</commit_message>
<xml_diff>
--- a/deliverables/Audio_Architecture_Presentation_Final.pptx
+++ b/deliverables/Audio_Architecture_Presentation_Final.pptx
@@ -449,7 +449,7 @@
           <a:lstStyle xmlns:a="http://schemas.openxmlformats.org/drawingml/2006/main"/>
           <a:p xmlns:a="http://schemas.openxmlformats.org/drawingml/2006/main">
             <a:r>
-              <a:t>Source: repository implementation and docs/TEST_RESULTS.json, verified locally 19 October 2026. The 12-case engine comparison uses the original 48-track catalog. No AWS deployment has been verified. Custom tracks contain metadata only; M3U exports need user-supplied audio files.</a:t>
+              <a:t>Source: repository implementation and docs/TEST_RESULTS.json, verified locally 22 October 2026. The 12-case engine comparison uses the original 48-track catalog. No AWS deployment has been verified. Custom tracks contain metadata only; M3U exports need user-supplied audio files.</a:t>
             </a:r>
           </a:p>
         </p:txBody>
@@ -519,7 +519,7 @@
           <a:lstStyle xmlns:a="http://schemas.openxmlformats.org/drawingml/2006/main"/>
           <a:p xmlns:a="http://schemas.openxmlformats.org/drawingml/2006/main">
             <a:r>
-              <a:t>Source: repository implementation and docs/TEST_RESULTS.json, verified locally 19 October 2026. The 12-case engine comparison uses the original 48-track catalog. No AWS deployment has been verified. Custom tracks contain metadata only; M3U exports need user-supplied audio files.</a:t>
+              <a:t>Source: repository implementation and docs/TEST_RESULTS.json, verified locally 22 October 2026. The 12-case engine comparison uses the original 48-track catalog. No AWS deployment has been verified. Custom tracks contain metadata only; M3U exports need user-supplied audio files.</a:t>
             </a:r>
           </a:p>
         </p:txBody>
@@ -589,7 +589,7 @@
           <a:lstStyle xmlns:a="http://schemas.openxmlformats.org/drawingml/2006/main"/>
           <a:p xmlns:a="http://schemas.openxmlformats.org/drawingml/2006/main">
             <a:r>
-              <a:t>Source: repository implementation and docs/TEST_RESULTS.json, verified locally 19 October 2026. The 12-case engine comparison uses the original 48-track catalog. No AWS deployment has been verified. Custom tracks contain metadata only; M3U exports need user-supplied audio files.</a:t>
+              <a:t>Source: repository implementation and docs/TEST_RESULTS.json, verified locally 22 October 2026. The 12-case engine comparison uses the original 48-track catalog. No AWS deployment has been verified. Custom tracks contain metadata only; M3U exports need user-supplied audio files.</a:t>
             </a:r>
           </a:p>
         </p:txBody>
@@ -659,7 +659,7 @@
           <a:lstStyle xmlns:a="http://schemas.openxmlformats.org/drawingml/2006/main"/>
           <a:p xmlns:a="http://schemas.openxmlformats.org/drawingml/2006/main">
             <a:r>
-              <a:t>Source: repository implementation and docs/TEST_RESULTS.json, verified locally 19 October 2026. The 12-case engine comparison uses the original 48-track catalog. No AWS deployment has been verified. Custom tracks contain metadata only; M3U exports need user-supplied audio files.</a:t>
+              <a:t>Source: repository implementation and docs/TEST_RESULTS.json, verified locally 22 October 2026. The 12-case engine comparison uses the original 48-track catalog. No AWS deployment has been verified. Custom tracks contain metadata only; M3U exports need user-supplied audio files.</a:t>
             </a:r>
           </a:p>
         </p:txBody>
@@ -729,7 +729,7 @@
           <a:lstStyle xmlns:a="http://schemas.openxmlformats.org/drawingml/2006/main"/>
           <a:p xmlns:a="http://schemas.openxmlformats.org/drawingml/2006/main">
             <a:r>
-              <a:t>Source: repository implementation and docs/TEST_RESULTS.json, verified locally 19 October 2026. The 12-case engine comparison uses the original 48-track catalog. No AWS deployment has been verified. Custom tracks contain metadata only; M3U exports need user-supplied audio files.</a:t>
+              <a:t>Source: repository implementation and docs/TEST_RESULTS.json, verified locally 22 October 2026. The 12-case engine comparison uses the original 48-track catalog. No AWS deployment has been verified. Custom tracks contain metadata only; M3U exports need user-supplied audio files.</a:t>
             </a:r>
           </a:p>
         </p:txBody>
@@ -799,7 +799,7 @@
           <a:lstStyle xmlns:a="http://schemas.openxmlformats.org/drawingml/2006/main"/>
           <a:p xmlns:a="http://schemas.openxmlformats.org/drawingml/2006/main">
             <a:r>
-              <a:t>Source: repository implementation and docs/TEST_RESULTS.json, verified locally 19 October 2026. The 12-case engine comparison uses the original 48-track catalog. No AWS deployment has been verified. Custom tracks contain metadata only; M3U exports need user-supplied audio files.</a:t>
+              <a:t>Source: repository implementation and docs/TEST_RESULTS.json, verified locally 22 October 2026. The 12-case engine comparison uses the original 48-track catalog. No AWS deployment has been verified. Custom tracks contain metadata only; M3U exports need user-supplied audio files.</a:t>
             </a:r>
           </a:p>
         </p:txBody>
@@ -869,7 +869,7 @@
           <a:lstStyle xmlns:a="http://schemas.openxmlformats.org/drawingml/2006/main"/>
           <a:p xmlns:a="http://schemas.openxmlformats.org/drawingml/2006/main">
             <a:r>
-              <a:t>Source: repository implementation and docs/TEST_RESULTS.json, verified locally 19 October 2026. The 12-case engine comparison uses the original 48-track catalog. No AWS deployment has been verified. Custom tracks contain metadata only; M3U exports need user-supplied audio files.</a:t>
+              <a:t>Source: repository implementation and docs/TEST_RESULTS.json, verified locally 22 October 2026. The 12-case engine comparison uses the original 48-track catalog. No AWS deployment has been verified. Custom tracks contain metadata only; M3U exports need user-supplied audio files.</a:t>
             </a:r>
           </a:p>
         </p:txBody>
@@ -939,7 +939,7 @@
           <a:lstStyle xmlns:a="http://schemas.openxmlformats.org/drawingml/2006/main"/>
           <a:p xmlns:a="http://schemas.openxmlformats.org/drawingml/2006/main">
             <a:r>
-              <a:t>Source: repository implementation and docs/TEST_RESULTS.json, verified locally 19 October 2026. The 12-case engine comparison uses the original 48-track catalog. No AWS deployment has been verified. Custom tracks contain metadata only; M3U exports need user-supplied audio files.</a:t>
+              <a:t>Source: repository implementation and docs/TEST_RESULTS.json, verified locally 22 October 2026. The 12-case engine comparison uses the original 48-track catalog. No AWS deployment has been verified. Custom tracks contain metadata only; M3U exports need user-supplied audio files.</a:t>
             </a:r>
           </a:p>
         </p:txBody>
@@ -3902,7 +3902,7 @@
                 <a:ea typeface="Arial"/>
                 <a:cs typeface="Arial"/>
               </a:rPr>
-              <a:t>React builder captures duration, genres, and custom track metadata.</a:t>
+              <a:t>React builder captures duration, genres, energy shape and custom tracks.</a:t>
             </a:r>
           </a:p>
           <a:p xmlns:a="http://schemas.openxmlformats.org/drawingml/2006/main">
@@ -3974,7 +3974,7 @@
                 <a:ea typeface="Arial"/>
                 <a:cs typeface="Arial"/>
               </a:rPr>
-              <a:t>Extended M3U, JSON, and CSV exports contain tracklist metadata.</a:t>
+              <a:t>M3U, JSON and CSV exports are built only from stored playlists.</a:t>
             </a:r>
           </a:p>
         </p:txBody>
@@ -4631,7 +4631,7 @@
                 <a:ea typeface="Arial"/>
                 <a:cs typeface="Arial"/>
               </a:rPr>
-              <a:t>GitHub Actions runs tests and Terraform checks on each push.</a:t>
+              <a:t>GitHub Actions tests every push; API Gateway throttles to 5 req/s.</a:t>
             </a:r>
           </a:p>
           <a:p xmlns:a="http://schemas.openxmlformats.org/drawingml/2006/main">
@@ -4655,7 +4655,7 @@
                 <a:ea typeface="Arial"/>
                 <a:cs typeface="Arial"/>
               </a:rPr>
-              <a:t>AWS deployment is gated until the account, OIDC role, and state bucket are ready.</a:t>
+              <a:t>Gated deploy: approve the Terraform plan, then approve its apply.</a:t>
             </a:r>
           </a:p>
         </p:txBody>
@@ -4818,7 +4818,7 @@
                 <a:ea typeface="Arial"/>
                 <a:cs typeface="Arial"/>
               </a:rPr>
-              <a:t>41 backend tests pass. Frontend lint and build pass.</a:t>
+              <a:t>43 backend tests pass. Frontend lint and build pass.</a:t>
             </a:r>
           </a:p>
           <a:p xmlns:a="http://schemas.openxmlformats.org/drawingml/2006/main">
@@ -5125,7 +5125,7 @@
                 <a:ea typeface="Arial"/>
                 <a:cs typeface="Arial"/>
               </a:rPr>
-              <a:t>AWS deployment remains pending account setup and CI validation.</a:t>
+              <a:t>CI checks pass; AWS deployment remains pending account setup.</a:t>
             </a:r>
           </a:p>
         </p:txBody>

</xml_diff>